<commit_message>
수정본(_edit)을 assistant_process.pptx 하나로 합침
- 다른 곳에서 올린 수정본 반영: 문제 정의를 "출발과 목표" 2칸으로, 3쪽 제목을 "비슷한 도구와 차이"로, 4쪽 첫 열을 "비슷한 도구는"으로
- build.js에 옮겨 재빌드해도 수정이 사라지지 않게 함 (13장 전체 문구가 수정본과 동일함을 확인)
- 2쪽 발표자 노트를 바뀐 슬라이드에 맞게 수정
- assistant_process_edit.pptx 삭제 (파일명을 하나로 통일하는 규칙)
- DEVLOG에 바뀐 이유 반영

Co-Authored-By: Claude Sonnet 5.5 <noreply@anthropic.com>
</commit_message>
<xml_diff>
--- a/pythonpra/myproject/ppt/assistant_process.pptx
+++ b/pythonpra/myproject/ppt/assistant_process.pptx
@@ -954,7 +954,7 @@
           <a:p>
             <a:r>
               <a:rPr lang="en-US" dirty="0"/>
-              <a:t>[0:50 / 누적 1:10] 수어 인식 프로젝트에서 MediaPipe 손 인식을 써 본 뒤, 이걸 어디에 더 쓸 수 있을까 고민했다. 동작이 정해져 있으면 사용자가 원하는 대로 못 쓴다는 점을 문제로 잡았고, 목표는 클릭과 예/아니오를 뺀 모든 동작을 사용자가 정의하는 것.</a:t>
+              <a:t>[0:50 / 누적 1:10] 수어 인식 프로젝트에서 MediaPipe 손 인식을 써 본 뒤, 이걸 어디에 더 쓸 수 있을까 고민했다. 정해진 제스처 대신 내가 원하는 동작을 직접 붙여 보고 싶었고, 그래서 클릭과 예/아니오를 뺀 모든 동작을 사용자가 정의하는 것을 목표로 잡았다.</a:t>
             </a:r>
             <a:endParaRPr lang="en-US" dirty="0"/>
           </a:p>
@@ -4259,7 +4259,7 @@
                 <a:ea typeface="Malgun Gothic" pitchFamily="34" charset="-122"/>
                 <a:cs typeface="Malgun Gothic" pitchFamily="34" charset="-120"/>
               </a:rPr>
-              <a:t>문제 정의</a:t>
+              <a:t>출발과 목표</a:t>
             </a:r>
             <a:endParaRPr lang="en-US" sz="3200" dirty="0"/>
           </a:p>
@@ -4274,11 +4274,11 @@
         <p:spPr>
           <a:xfrm>
             <a:off x="548640" y="2011680"/>
-            <a:ext cx="2423160" cy="3108960"/>
+            <a:ext cx="5276088" cy="3108960"/>
           </a:xfrm>
           <a:prstGeom prst="roundRect">
             <a:avLst>
-              <a:gd name="adj" fmla="val 3019"/>
+              <a:gd name="adj" fmla="val 2353"/>
             </a:avLst>
           </a:prstGeom>
           <a:solidFill>
@@ -4307,8 +4307,8 @@
         </p:nvSpPr>
         <p:spPr>
           <a:xfrm>
-            <a:off x="731520" y="2240280"/>
-            <a:ext cx="2057400" cy="2651760"/>
+            <a:off x="740664" y="2240280"/>
+            <a:ext cx="4901184" cy="2651760"/>
           </a:xfrm>
           <a:prstGeom prst="rect">
             <a:avLst/>
@@ -4369,8 +4369,8 @@
         </p:nvSpPr>
         <p:spPr>
           <a:xfrm>
-            <a:off x="2971800" y="2011680"/>
-            <a:ext cx="457200" cy="3108960"/>
+            <a:off x="5824728" y="2011680"/>
+            <a:ext cx="512064" cy="3108960"/>
           </a:xfrm>
           <a:prstGeom prst="rect">
             <a:avLst/>
@@ -4408,275 +4408,12 @@
         </p:nvSpPr>
         <p:spPr>
           <a:xfrm>
-            <a:off x="3429000" y="2011680"/>
-            <a:ext cx="2423160" cy="3108960"/>
+            <a:off x="6336792" y="2011680"/>
+            <a:ext cx="5276088" cy="3108960"/>
           </a:xfrm>
           <a:prstGeom prst="roundRect">
             <a:avLst>
-              <a:gd name="adj" fmla="val 3019"/>
-            </a:avLst>
-          </a:prstGeom>
-          <a:solidFill>
-            <a:srgbClr val="FFFFFF"/>
-          </a:solidFill>
-          <a:ln w="12700">
-            <a:solidFill>
-              <a:srgbClr val="FFFFFF"/>
-            </a:solidFill>
-            <a:prstDash val="solid"/>
-          </a:ln>
-          <a:effectLst>
-            <a:outerShdw sx="100000" sy="100000" kx="0" ky="0" algn="bl" rotWithShape="0" blurRad="76200" dist="25400" dir="5400000">
-              <a:srgbClr val="000000">
-                <a:alpha val="12000"/>
-              </a:srgbClr>
-            </a:outerShdw>
-          </a:effectLst>
-        </p:spPr>
-      </p:sp>
-      <p:sp>
-        <p:nvSpPr>
-          <p:cNvPr id="8" name="Text 5"/>
-          <p:cNvSpPr txBox="1"/>
-          <p:nvPr/>
-        </p:nvSpPr>
-        <p:spPr>
-          <a:xfrm>
-            <a:off x="3611880" y="2240280"/>
-            <a:ext cx="2057400" cy="2651760"/>
-          </a:xfrm>
-          <a:prstGeom prst="rect">
-            <a:avLst/>
-          </a:prstGeom>
-          <a:noFill/>
-          <a:ln/>
-        </p:spPr>
-        <p:txBody>
-          <a:bodyPr wrap="square" lIns="0" tIns="0" rIns="0" bIns="0" rtlCol="0" anchor="t"/>
-          <a:lstStyle/>
-          <a:p>
-            <a:pPr indent="0" marL="0">
-              <a:spcAft>
-                <a:spcPts val="400"/>
-              </a:spcAft>
-              <a:buNone/>
-            </a:pPr>
-            <a:r>
-              <a:rPr lang="en-US" sz="2400" b="1" dirty="0">
-                <a:solidFill>
-                  <a:srgbClr val="1B2230"/>
-                </a:solidFill>
-                <a:latin typeface="Malgun Gothic" pitchFamily="34" charset="0"/>
-                <a:ea typeface="Malgun Gothic" pitchFamily="34" charset="-122"/>
-                <a:cs typeface="Malgun Gothic" pitchFamily="34" charset="-120"/>
-              </a:rPr>
-              <a:t>질문</a:t>
-            </a:r>
-            <a:endParaRPr lang="en-US" sz="1400" dirty="0"/>
-          </a:p>
-          <a:p>
-            <a:pPr indent="0" marL="0">
-              <a:spcAft>
-                <a:spcPts val="400"/>
-              </a:spcAft>
-              <a:buNone/>
-            </a:pPr>
-            <a:r>
-              <a:rPr lang="en-US" sz="2100" dirty="0">
-                <a:solidFill>
-                  <a:srgbClr val="1B2230"/>
-                </a:solidFill>
-                <a:latin typeface="Malgun Gothic" pitchFamily="34" charset="0"/>
-                <a:ea typeface="Malgun Gothic" pitchFamily="34" charset="-122"/>
-                <a:cs typeface="Malgun Gothic" pitchFamily="34" charset="-120"/>
-              </a:rPr>
-              <a:t>이 손 인식을 어디에 더 쓸 수 있을까</a:t>
-            </a:r>
-            <a:endParaRPr lang="en-US" sz="1400" dirty="0"/>
-          </a:p>
-        </p:txBody>
-      </p:sp>
-      <p:sp>
-        <p:nvSpPr>
-          <p:cNvPr id="9" name="Text 6"/>
-          <p:cNvSpPr txBox="1"/>
-          <p:nvPr/>
-        </p:nvSpPr>
-        <p:spPr>
-          <a:xfrm>
-            <a:off x="5852160" y="2011680"/>
-            <a:ext cx="457200" cy="3108960"/>
-          </a:xfrm>
-          <a:prstGeom prst="rect">
-            <a:avLst/>
-          </a:prstGeom>
-          <a:noFill/>
-          <a:ln/>
-        </p:spPr>
-        <p:txBody>
-          <a:bodyPr wrap="square" lIns="0" tIns="0" rIns="0" bIns="0" rtlCol="0" anchor="ctr"/>
-          <a:lstStyle/>
-          <a:p>
-            <a:pPr algn="ctr" indent="0" marL="0">
-              <a:buNone/>
-            </a:pPr>
-            <a:r>
-              <a:rPr lang="en-US" sz="2400" dirty="0">
-                <a:solidFill>
-                  <a:srgbClr val="6A7384"/>
-                </a:solidFill>
-                <a:latin typeface="Malgun Gothic" pitchFamily="34" charset="0"/>
-                <a:ea typeface="Malgun Gothic" pitchFamily="34" charset="-122"/>
-                <a:cs typeface="Malgun Gothic" pitchFamily="34" charset="-120"/>
-              </a:rPr>
-              <a:t>→</a:t>
-            </a:r>
-            <a:endParaRPr lang="en-US" sz="2400" dirty="0"/>
-          </a:p>
-        </p:txBody>
-      </p:sp>
-      <p:sp>
-        <p:nvSpPr>
-          <p:cNvPr id="10" name="Shape 7"/>
-          <p:cNvSpPr/>
-          <p:nvPr/>
-        </p:nvSpPr>
-        <p:spPr>
-          <a:xfrm>
-            <a:off x="6309360" y="2011680"/>
-            <a:ext cx="2423160" cy="3108960"/>
-          </a:xfrm>
-          <a:prstGeom prst="roundRect">
-            <a:avLst>
-              <a:gd name="adj" fmla="val 3019"/>
-            </a:avLst>
-          </a:prstGeom>
-          <a:solidFill>
-            <a:srgbClr val="FBE9E7"/>
-          </a:solidFill>
-          <a:ln w="12700">
-            <a:solidFill>
-              <a:srgbClr val="FBE9E7"/>
-            </a:solidFill>
-            <a:prstDash val="solid"/>
-          </a:ln>
-        </p:spPr>
-      </p:sp>
-      <p:sp>
-        <p:nvSpPr>
-          <p:cNvPr id="11" name="Text 8"/>
-          <p:cNvSpPr txBox="1"/>
-          <p:nvPr/>
-        </p:nvSpPr>
-        <p:spPr>
-          <a:xfrm>
-            <a:off x="6492240" y="2240280"/>
-            <a:ext cx="2057400" cy="2651760"/>
-          </a:xfrm>
-          <a:prstGeom prst="rect">
-            <a:avLst/>
-          </a:prstGeom>
-          <a:noFill/>
-          <a:ln/>
-        </p:spPr>
-        <p:txBody>
-          <a:bodyPr wrap="square" lIns="0" tIns="0" rIns="0" bIns="0" rtlCol="0" anchor="t"/>
-          <a:lstStyle/>
-          <a:p>
-            <a:pPr indent="0" marL="0">
-              <a:spcAft>
-                <a:spcPts val="400"/>
-              </a:spcAft>
-              <a:buNone/>
-            </a:pPr>
-            <a:r>
-              <a:rPr lang="en-US" sz="2400" b="1" dirty="0">
-                <a:solidFill>
-                  <a:srgbClr val="C8443A"/>
-                </a:solidFill>
-                <a:latin typeface="Malgun Gothic" pitchFamily="34" charset="0"/>
-                <a:ea typeface="Malgun Gothic" pitchFamily="34" charset="-122"/>
-                <a:cs typeface="Malgun Gothic" pitchFamily="34" charset="-120"/>
-              </a:rPr>
-              <a:t>문제</a:t>
-            </a:r>
-            <a:endParaRPr lang="en-US" sz="1400" dirty="0"/>
-          </a:p>
-          <a:p>
-            <a:pPr indent="0" marL="0">
-              <a:spcAft>
-                <a:spcPts val="400"/>
-              </a:spcAft>
-              <a:buNone/>
-            </a:pPr>
-            <a:r>
-              <a:rPr lang="en-US" sz="2100" dirty="0">
-                <a:solidFill>
-                  <a:srgbClr val="1B2230"/>
-                </a:solidFill>
-                <a:latin typeface="Malgun Gothic" pitchFamily="34" charset="0"/>
-                <a:ea typeface="Malgun Gothic" pitchFamily="34" charset="-122"/>
-                <a:cs typeface="Malgun Gothic" pitchFamily="34" charset="-120"/>
-              </a:rPr>
-              <a:t>동작이 정해져 있으면 사용자가 원하는 대로 쓸 수 없다</a:t>
-            </a:r>
-            <a:endParaRPr lang="en-US" sz="1400" dirty="0"/>
-          </a:p>
-        </p:txBody>
-      </p:sp>
-      <p:sp>
-        <p:nvSpPr>
-          <p:cNvPr id="12" name="Text 9"/>
-          <p:cNvSpPr txBox="1"/>
-          <p:nvPr/>
-        </p:nvSpPr>
-        <p:spPr>
-          <a:xfrm>
-            <a:off x="8732520" y="2011680"/>
-            <a:ext cx="457200" cy="3108960"/>
-          </a:xfrm>
-          <a:prstGeom prst="rect">
-            <a:avLst/>
-          </a:prstGeom>
-          <a:noFill/>
-          <a:ln/>
-        </p:spPr>
-        <p:txBody>
-          <a:bodyPr wrap="square" lIns="0" tIns="0" rIns="0" bIns="0" rtlCol="0" anchor="ctr"/>
-          <a:lstStyle/>
-          <a:p>
-            <a:pPr algn="ctr" indent="0" marL="0">
-              <a:buNone/>
-            </a:pPr>
-            <a:r>
-              <a:rPr lang="en-US" sz="2400" dirty="0">
-                <a:solidFill>
-                  <a:srgbClr val="6A7384"/>
-                </a:solidFill>
-                <a:latin typeface="Malgun Gothic" pitchFamily="34" charset="0"/>
-                <a:ea typeface="Malgun Gothic" pitchFamily="34" charset="-122"/>
-                <a:cs typeface="Malgun Gothic" pitchFamily="34" charset="-120"/>
-              </a:rPr>
-              <a:t>→</a:t>
-            </a:r>
-            <a:endParaRPr lang="en-US" sz="2400" dirty="0"/>
-          </a:p>
-        </p:txBody>
-      </p:sp>
-      <p:sp>
-        <p:nvSpPr>
-          <p:cNvPr id="13" name="Shape 10"/>
-          <p:cNvSpPr/>
-          <p:nvPr/>
-        </p:nvSpPr>
-        <p:spPr>
-          <a:xfrm>
-            <a:off x="9189720" y="2011680"/>
-            <a:ext cx="2423160" cy="3108960"/>
-          </a:xfrm>
-          <a:prstGeom prst="roundRect">
-            <a:avLst>
-              <a:gd name="adj" fmla="val 3019"/>
+              <a:gd name="adj" fmla="val 2353"/>
             </a:avLst>
           </a:prstGeom>
           <a:solidFill>
@@ -4692,14 +4429,14 @@
       </p:sp>
       <p:sp>
         <p:nvSpPr>
-          <p:cNvPr id="14" name="Text 11"/>
+          <p:cNvPr id="8" name="Text 5"/>
           <p:cNvSpPr txBox="1"/>
           <p:nvPr/>
         </p:nvSpPr>
         <p:spPr>
           <a:xfrm>
-            <a:off x="9372600" y="2240280"/>
-            <a:ext cx="2057400" cy="2651760"/>
+            <a:off x="6528816" y="2240280"/>
+            <a:ext cx="4901184" cy="2651760"/>
           </a:xfrm>
           <a:prstGeom prst="rect">
             <a:avLst/>
@@ -4746,7 +4483,7 @@
                 <a:ea typeface="Malgun Gothic" pitchFamily="34" charset="-122"/>
                 <a:cs typeface="Malgun Gothic" pitchFamily="34" charset="-120"/>
               </a:rPr>
-              <a:t>클릭 · 예/아니오를 뺀 모든 동작을 사용자가 직접 정의</a:t>
+              <a:t>정해진 제스처 대신 내가 원하는 동작을 직접 붙여 보고 싶어서. 클릭 · 예/아니오를 뺀 모든 동작을 직접 정의</a:t>
             </a:r>
             <a:endParaRPr lang="en-US" sz="1400" dirty="0"/>
           </a:p>
@@ -4817,7 +4554,7 @@
                 <a:ea typeface="Malgun Gothic" pitchFamily="34" charset="-122"/>
                 <a:cs typeface="Malgun Gothic" pitchFamily="34" charset="-120"/>
               </a:rPr>
-              <a:t>기존 방법과 한계</a:t>
+              <a:t>비슷한 도구와 차이</a:t>
             </a:r>
             <a:endParaRPr lang="en-US" sz="3200" dirty="0"/>
           </a:p>
@@ -6402,7 +6139,7 @@
                 <a:ea typeface="Malgun Gothic" pitchFamily="34" charset="-122"/>
                 <a:cs typeface="Malgun Gothic" pitchFamily="34" charset="-120"/>
               </a:rPr>
-              <a:t>아쉬운 점</a:t>
+              <a:t>비슷한 도구는</a:t>
             </a:r>
             <a:endParaRPr lang="en-US" sz="1400" dirty="0"/>
           </a:p>

</xml_diff>